<commit_message>
Slides: transitions' side and speed and animations' side and speed chosen (Options strips), exits (disappear, fade out, fly out) read, played, chosen and saved; a group chosen as a whole — moved, sized, coloured, animated — and its shapes' words typed; effects.pptx has a group
Co-Authored-By: Claude Opus 5.5 <noreply@anthropic.com>
</commit_message>
<xml_diff>
--- a/app/src/test/resources/effects.pptx
+++ b/app/src/test/resources/effects.pptx
@@ -8,6 +8,7 @@
     <p:sldId id="256" r:id="rId7"/>
     <p:sldId id="257" r:id="rId8"/>
     <p:sldId id="258" r:id="rId9"/>
+    <p:sldId id="259" r:id="rId10"/>
   </p:sldIdLst>
   <p:sldSz cx="9144000" cy="6858000" type="screen4x3"/>
   <p:notesSz cx="6858000" cy="9144000"/>
@@ -3448,6 +3449,117 @@
       </p:par>
     </p:tnLst>
   </p:timing>
+</p:sld>
+</file>
+
+<file path=ppt/slides/slide4.xml><?xml version="1.0" encoding="utf-8"?>
+<p:sld xmlns:a="http://schemas.openxmlformats.org/drawingml/2006/main" xmlns:p="http://schemas.openxmlformats.org/presentationml/2006/main" xmlns:r="http://schemas.openxmlformats.org/officeDocument/2006/relationships">
+  <p:cSld>
+    <p:spTree>
+      <p:nvGrpSpPr>
+        <p:cNvPr id="1" name=""/>
+        <p:cNvGrpSpPr/>
+        <p:nvPr/>
+      </p:nvGrpSpPr>
+      <p:grpSpPr/>
+      <p:grpSp>
+        <p:nvGrpSpPr>
+          <p:cNvPr id="2" name="Group 1"/>
+          <p:cNvGrpSpPr/>
+          <p:nvPr/>
+        </p:nvGrpSpPr>
+        <p:grpSpPr>
+          <a:xfrm>
+            <a:off x="914400" y="914400"/>
+            <a:ext cx="4572000" cy="1828800"/>
+            <a:chOff x="914400" y="914400"/>
+            <a:chExt cx="4572000" cy="1828800"/>
+          </a:xfrm>
+        </p:grpSpPr>
+        <p:sp>
+          <p:nvSpPr>
+            <p:cNvPr id="3" name="Oval 2"/>
+            <p:cNvSpPr/>
+            <p:nvPr/>
+          </p:nvSpPr>
+          <p:spPr>
+            <a:xfrm>
+              <a:off x="914400" y="914400"/>
+              <a:ext cx="1828800" cy="1828800"/>
+            </a:xfrm>
+            <a:prstGeom prst="ellipse">
+              <a:avLst/>
+            </a:prstGeom>
+          </p:spPr>
+          <p:style>
+            <a:lnRef idx="1">
+              <a:schemeClr val="accent1"/>
+            </a:lnRef>
+            <a:fillRef idx="3">
+              <a:schemeClr val="accent1"/>
+            </a:fillRef>
+            <a:effectRef idx="2">
+              <a:schemeClr val="accent1"/>
+            </a:effectRef>
+            <a:fontRef idx="minor">
+              <a:schemeClr val="lt1"/>
+            </a:fontRef>
+          </p:style>
+          <p:txBody>
+            <a:bodyPr rtlCol="0" anchor="ctr"/>
+            <a:lstStyle/>
+            <a:p>
+              <a:r>
+                <a:t>One</a:t>
+              </a:r>
+            </a:p>
+          </p:txBody>
+        </p:sp>
+        <p:sp>
+          <p:nvSpPr>
+            <p:cNvPr id="4" name="Rectangle 3"/>
+            <p:cNvSpPr/>
+            <p:nvPr/>
+          </p:nvSpPr>
+          <p:spPr>
+            <a:xfrm>
+              <a:off x="3657600" y="1828800"/>
+              <a:ext cx="1828800" cy="914400"/>
+            </a:xfrm>
+            <a:prstGeom prst="rect">
+              <a:avLst/>
+            </a:prstGeom>
+          </p:spPr>
+          <p:style>
+            <a:lnRef idx="1">
+              <a:schemeClr val="accent1"/>
+            </a:lnRef>
+            <a:fillRef idx="3">
+              <a:schemeClr val="accent1"/>
+            </a:fillRef>
+            <a:effectRef idx="2">
+              <a:schemeClr val="accent1"/>
+            </a:effectRef>
+            <a:fontRef idx="minor">
+              <a:schemeClr val="lt1"/>
+            </a:fontRef>
+          </p:style>
+          <p:txBody>
+            <a:bodyPr rtlCol="0" anchor="ctr"/>
+            <a:lstStyle/>
+            <a:p>
+              <a:r>
+                <a:t>Two</a:t>
+              </a:r>
+            </a:p>
+          </p:txBody>
+        </p:sp>
+      </p:grpSp>
+    </p:spTree>
+  </p:cSld>
+  <p:clrMapOvr>
+    <a:masterClrMapping/>
+  </p:clrMapOvr>
 </p:sld>
 </file>
 

</xml_diff>